<commit_message>
feat: optimización de pipeline ETL, DAGs Airflow, métricas de auditoría y entregables INF-522
</commit_message>
<xml_diff>
--- a/presentacion/Presentacion_INF522_Gestion_Datos_Astronomicos.pptx
+++ b/presentacion/Presentacion_INF522_Gestion_Datos_Astronomicos.pptx
@@ -6882,22 +6882,22 @@
               </a:defRPr>
             </a:pPr>
             <a:r>
-              <a:t>• Fórmula: SUM(tiempo_exposicion_seg) / 3600.</a:t>
-            </a:r>
-          </a:p>
-          <a:p>
-            <a:pPr>
-              <a:spcAft>
-                <a:spcPts val="600"/>
-              </a:spcAft>
-              <a:defRPr sz="1300">
-                <a:solidFill>
-                  <a:srgbClr val="CBD5E1"/>
-                </a:solidFill>
-              </a:defRPr>
-            </a:pPr>
-            <a:r>
-              <a:t>• Objetivo: Medir el aprovechamiento nocturno en Paranal y La Silla por telescopio e instrumento.</a:t>
+              <a:t>• Fórmula: SUM(tiempo_exposicion_seg) / 3600 por instalación (facility).</a:t>
+            </a:r>
+          </a:p>
+          <a:p>
+            <a:pPr>
+              <a:spcAft>
+                <a:spcPts val="600"/>
+              </a:spcAft>
+              <a:defRPr sz="1300">
+                <a:solidFill>
+                  <a:srgbClr val="CBD5E1"/>
+                </a:solidFill>
+              </a:defRPr>
+            </a:pPr>
+            <a:r>
+              <a:t>• Objetivo: Medir el aprovechamiento nocturno conjunto en Paranal, La Silla y Chajnantor.</a:t>
             </a:r>
           </a:p>
           <a:p>
@@ -6942,7 +6942,7 @@
               </a:defRPr>
             </a:pPr>
             <a:r>
-              <a:t>• Hallazgo: Telescopios como FEROS y HARPS alcanzan entre 4 y 7 horas útiles por noche despejada.</a:t>
+              <a:t>• Hallazgo: Telescopios como ESO-3.6 (HARPS + NIRPS) y ALMA acumulan entre 5 y 8 horas de observación útil por noche.</a:t>
             </a:r>
           </a:p>
         </p:txBody>
@@ -7581,7 +7581,7 @@
               </a:defRPr>
             </a:pPr>
             <a:r>
-              <a:t>• Objetivo: Identificar 'zonas ciegas' donde surgen muchas alertas en cielo chileno pero falta tiempo de telescopio.</a:t>
+              <a:t>• Objetivo: Identificar zonas del cielo con alertas transitorias frente al tiempo de seguimiento asignado en Chile.</a:t>
             </a:r>
           </a:p>
           <a:p>
@@ -7626,7 +7626,22 @@
               </a:defRPr>
             </a:pPr>
             <a:r>
-              <a:t>• Hallazgo: Se detectaron bandas australes con déficit de seguimiento (0 min de exposición frente a decenas de alertas).</a:t>
+              <a:t>• Ramas de Diagnóstico: Cobertura óptima (&gt;= 5 min), parcial (&lt; 5 min), déficit (0 min) y observación austral sin alertas activas.</a:t>
+            </a:r>
+          </a:p>
+          <a:p>
+            <a:pPr>
+              <a:spcAft>
+                <a:spcPts val="600"/>
+              </a:spcAft>
+              <a:defRPr sz="1300">
+                <a:solidFill>
+                  <a:srgbClr val="CBD5E1"/>
+                </a:solidFill>
+              </a:defRPr>
+            </a:pPr>
+            <a:r>
+              <a:t>• Hallazgo: En octubre 2026 se observan bandas australes con seguimiento intensivo de ESO y franjas con alertas transitorias en espera de seguimiento.</a:t>
             </a:r>
           </a:p>
         </p:txBody>

</xml_diff>